<commit_message>
Programming, ML, Advanced DL
</commit_message>
<xml_diff>
--- a/ComputerProgramming-SmartManufacturing/Class 01 Introduction/Class 01 - Introduction.pptx
+++ b/ComputerProgramming-SmartManufacturing/Class 01 Introduction/Class 01 - Introduction.pptx
@@ -6517,7 +6517,7 @@
           <a:p>
             <a:fld id="{B6A752C3-6E00-4778-84BC-64D65AC061B8}" type="datetimeFigureOut">
               <a:rPr lang="en-US" smtClean="0"/>
-              <a:t>5/11/2025</a:t>
+              <a:t>8/12/2025</a:t>
             </a:fld>
             <a:endParaRPr lang="en-US"/>
           </a:p>
@@ -6715,7 +6715,7 @@
           <a:p>
             <a:fld id="{B6A752C3-6E00-4778-84BC-64D65AC061B8}" type="datetimeFigureOut">
               <a:rPr lang="en-US" smtClean="0"/>
-              <a:t>5/11/2025</a:t>
+              <a:t>8/12/2025</a:t>
             </a:fld>
             <a:endParaRPr lang="en-US"/>
           </a:p>
@@ -6923,7 +6923,7 @@
           <a:p>
             <a:fld id="{B6A752C3-6E00-4778-84BC-64D65AC061B8}" type="datetimeFigureOut">
               <a:rPr lang="en-US" smtClean="0"/>
-              <a:t>5/11/2025</a:t>
+              <a:t>8/12/2025</a:t>
             </a:fld>
             <a:endParaRPr lang="en-US"/>
           </a:p>
@@ -8009,7 +8009,7 @@
           <a:p>
             <a:fld id="{B6A752C3-6E00-4778-84BC-64D65AC061B8}" type="datetimeFigureOut">
               <a:rPr lang="en-US" smtClean="0"/>
-              <a:t>5/11/2025</a:t>
+              <a:t>8/12/2025</a:t>
             </a:fld>
             <a:endParaRPr lang="en-US"/>
           </a:p>
@@ -8284,7 +8284,7 @@
           <a:p>
             <a:fld id="{B6A752C3-6E00-4778-84BC-64D65AC061B8}" type="datetimeFigureOut">
               <a:rPr lang="en-US" smtClean="0"/>
-              <a:t>5/11/2025</a:t>
+              <a:t>8/12/2025</a:t>
             </a:fld>
             <a:endParaRPr lang="en-US"/>
           </a:p>
@@ -8549,7 +8549,7 @@
           <a:p>
             <a:fld id="{B6A752C3-6E00-4778-84BC-64D65AC061B8}" type="datetimeFigureOut">
               <a:rPr lang="en-US" smtClean="0"/>
-              <a:t>5/11/2025</a:t>
+              <a:t>8/12/2025</a:t>
             </a:fld>
             <a:endParaRPr lang="en-US"/>
           </a:p>
@@ -8961,7 +8961,7 @@
           <a:p>
             <a:fld id="{B6A752C3-6E00-4778-84BC-64D65AC061B8}" type="datetimeFigureOut">
               <a:rPr lang="en-US" smtClean="0"/>
-              <a:t>5/11/2025</a:t>
+              <a:t>8/12/2025</a:t>
             </a:fld>
             <a:endParaRPr lang="en-US"/>
           </a:p>
@@ -9102,7 +9102,7 @@
           <a:p>
             <a:fld id="{B6A752C3-6E00-4778-84BC-64D65AC061B8}" type="datetimeFigureOut">
               <a:rPr lang="en-US" smtClean="0"/>
-              <a:t>5/11/2025</a:t>
+              <a:t>8/12/2025</a:t>
             </a:fld>
             <a:endParaRPr lang="en-US"/>
           </a:p>
@@ -9215,7 +9215,7 @@
           <a:p>
             <a:fld id="{B6A752C3-6E00-4778-84BC-64D65AC061B8}" type="datetimeFigureOut">
               <a:rPr lang="en-US" smtClean="0"/>
-              <a:t>5/11/2025</a:t>
+              <a:t>8/12/2025</a:t>
             </a:fld>
             <a:endParaRPr lang="en-US"/>
           </a:p>
@@ -9526,7 +9526,7 @@
           <a:p>
             <a:fld id="{B6A752C3-6E00-4778-84BC-64D65AC061B8}" type="datetimeFigureOut">
               <a:rPr lang="en-US" smtClean="0"/>
-              <a:t>5/11/2025</a:t>
+              <a:t>8/12/2025</a:t>
             </a:fld>
             <a:endParaRPr lang="en-US"/>
           </a:p>
@@ -9814,7 +9814,7 @@
           <a:p>
             <a:fld id="{B6A752C3-6E00-4778-84BC-64D65AC061B8}" type="datetimeFigureOut">
               <a:rPr lang="en-US" smtClean="0"/>
-              <a:t>5/11/2025</a:t>
+              <a:t>8/12/2025</a:t>
             </a:fld>
             <a:endParaRPr lang="en-US"/>
           </a:p>
@@ -10055,7 +10055,7 @@
           <a:p>
             <a:fld id="{B6A752C3-6E00-4778-84BC-64D65AC061B8}" type="datetimeFigureOut">
               <a:rPr lang="en-US" smtClean="0"/>
-              <a:t>5/11/2025</a:t>
+              <a:t>8/12/2025</a:t>
             </a:fld>
             <a:endParaRPr lang="en-US"/>
           </a:p>
@@ -16266,6 +16266,6 @@
 
 <file path=docMetadata/LabelInfo.xml><?xml version="1.0" encoding="utf-8"?>
 <clbl:labelList xmlns:clbl="http://schemas.microsoft.com/office/2020/mipLabelMetadata">
-  <clbl:label id="{f42aa342-8706-4288-bd11-ebb85995028c}" enabled="1" method="Standard" siteId="{72f988bf-86f1-41af-91ab-2d7cd011db47}" contentBits="0" removed="0"/>
+  <clbl:label id="{87ba5c36-b7cf-4793-bbc2-bd5b3a9f95ca}" enabled="1" method="Privileged" siteId="{72f988bf-86f1-41af-91ab-2d7cd011db47}" contentBits="0" removed="0"/>
 </clbl:labelList>
 </file>
</xml_diff>